<commit_message>
updated screenshots for V7 workspace package structure
</commit_message>
<xml_diff>
--- a/documentation/eapli.framework-Tech-Description.pptx
+++ b/documentation/eapli.framework-Tech-Description.pptx
@@ -16,8 +16,8 @@
     <p:sldId id="418" r:id="rId4"/>
     <p:sldId id="419" r:id="rId5"/>
     <p:sldId id="412" r:id="rId6"/>
-    <p:sldId id="376" r:id="rId7"/>
-    <p:sldId id="432" r:id="rId8"/>
+    <p:sldId id="445" r:id="rId7"/>
+    <p:sldId id="446" r:id="rId8"/>
     <p:sldId id="375" r:id="rId9"/>
     <p:sldId id="442" r:id="rId10"/>
     <p:sldId id="381" r:id="rId11"/>
@@ -290,7 +290,7 @@
             <a:fld id="{DF9BBED1-C878-4044-B70F-841416CAC1AE}" type="datetimeFigureOut">
               <a:rPr lang="en-US" smtClean="0"/>
               <a:pPr/>
-              <a:t>2/25/2019</a:t>
+              <a:t>3/18/2019</a:t>
             </a:fld>
             <a:endParaRPr lang="en-US"/>
           </a:p>
@@ -457,7 +457,7 @@
             <a:fld id="{754636F6-6535-4DFB-8291-07E7DDBE6239}" type="datetimeFigureOut">
               <a:rPr lang="pt-PT" smtClean="0"/>
               <a:pPr/>
-              <a:t>25/02/2019</a:t>
+              <a:t>18/03/2019</a:t>
             </a:fld>
             <a:endParaRPr lang="pt-PT"/>
           </a:p>
@@ -1951,7 +1951,7 @@
             <a:fld id="{1A3222AE-4D74-4601-B435-B179E428ACD9}" type="datetime1">
               <a:rPr lang="pt-PT" smtClean="0"/>
               <a:pPr/>
-              <a:t>25/02/2019</a:t>
+              <a:t>18/03/2019</a:t>
             </a:fld>
             <a:endParaRPr lang="pt-PT"/>
           </a:p>
@@ -2169,7 +2169,7 @@
             <a:fld id="{03643B1D-A57E-46BD-9617-845A2C51AEF7}" type="datetime1">
               <a:rPr lang="pt-PT" smtClean="0"/>
               <a:pPr/>
-              <a:t>25/02/2019</a:t>
+              <a:t>18/03/2019</a:t>
             </a:fld>
             <a:endParaRPr lang="pt-PT"/>
           </a:p>
@@ -2443,7 +2443,7 @@
             <a:fld id="{03643B1D-A57E-46BD-9617-845A2C51AEF7}" type="datetime1">
               <a:rPr lang="pt-PT" smtClean="0"/>
               <a:pPr/>
-              <a:t>25/02/2019</a:t>
+              <a:t>18/03/2019</a:t>
             </a:fld>
             <a:endParaRPr lang="pt-PT"/>
           </a:p>
@@ -2620,7 +2620,7 @@
             <a:fld id="{03643B1D-A57E-46BD-9617-845A2C51AEF7}" type="datetime1">
               <a:rPr lang="pt-PT" smtClean="0"/>
               <a:pPr/>
-              <a:t>25/02/2019</a:t>
+              <a:t>18/03/2019</a:t>
             </a:fld>
             <a:endParaRPr lang="pt-PT"/>
           </a:p>
@@ -2976,7 +2976,7 @@
             <a:fld id="{03643B1D-A57E-46BD-9617-845A2C51AEF7}" type="datetime1">
               <a:rPr lang="pt-PT" smtClean="0"/>
               <a:pPr/>
-              <a:t>25/02/2019</a:t>
+              <a:t>18/03/2019</a:t>
             </a:fld>
             <a:endParaRPr lang="pt-PT"/>
           </a:p>
@@ -3263,7 +3263,7 @@
             <a:fld id="{03643B1D-A57E-46BD-9617-845A2C51AEF7}" type="datetime1">
               <a:rPr lang="pt-PT" smtClean="0"/>
               <a:pPr/>
-              <a:t>25/02/2019</a:t>
+              <a:t>18/03/2019</a:t>
             </a:fld>
             <a:endParaRPr lang="pt-PT"/>
           </a:p>
@@ -3687,7 +3687,7 @@
             <a:fld id="{03643B1D-A57E-46BD-9617-845A2C51AEF7}" type="datetime1">
               <a:rPr lang="pt-PT" smtClean="0"/>
               <a:pPr/>
-              <a:t>25/02/2019</a:t>
+              <a:t>18/03/2019</a:t>
             </a:fld>
             <a:endParaRPr lang="pt-PT"/>
           </a:p>
@@ -3802,7 +3802,7 @@
             <a:fld id="{03643B1D-A57E-46BD-9617-845A2C51AEF7}" type="datetime1">
               <a:rPr lang="pt-PT" smtClean="0"/>
               <a:pPr/>
-              <a:t>25/02/2019</a:t>
+              <a:t>18/03/2019</a:t>
             </a:fld>
             <a:endParaRPr lang="pt-PT"/>
           </a:p>
@@ -3895,7 +3895,7 @@
             <a:fld id="{03643B1D-A57E-46BD-9617-845A2C51AEF7}" type="datetime1">
               <a:rPr lang="pt-PT" smtClean="0"/>
               <a:pPr/>
-              <a:t>25/02/2019</a:t>
+              <a:t>18/03/2019</a:t>
             </a:fld>
             <a:endParaRPr lang="pt-PT"/>
           </a:p>
@@ -4175,7 +4175,7 @@
             <a:fld id="{03643B1D-A57E-46BD-9617-845A2C51AEF7}" type="datetime1">
               <a:rPr lang="pt-PT" smtClean="0"/>
               <a:pPr/>
-              <a:t>25/02/2019</a:t>
+              <a:t>18/03/2019</a:t>
             </a:fld>
             <a:endParaRPr lang="pt-PT"/>
           </a:p>
@@ -4539,7 +4539,7 @@
             <a:fld id="{03643B1D-A57E-46BD-9617-845A2C51AEF7}" type="datetime1">
               <a:rPr lang="pt-PT" smtClean="0"/>
               <a:pPr/>
-              <a:t>25/02/2019</a:t>
+              <a:t>18/03/2019</a:t>
             </a:fld>
             <a:endParaRPr lang="pt-PT"/>
           </a:p>
@@ -4965,7 +4965,7 @@
             <a:fld id="{03643B1D-A57E-46BD-9617-845A2C51AEF7}" type="datetime1">
               <a:rPr lang="pt-PT" smtClean="0"/>
               <a:pPr/>
-              <a:t>25/02/2019</a:t>
+              <a:t>18/03/2019</a:t>
             </a:fld>
             <a:endParaRPr lang="pt-PT"/>
           </a:p>
@@ -12596,25 +12596,6 @@
       </p:sp>
       <p:sp>
         <p:nvSpPr>
-          <p:cNvPr id="4" name="Content Placeholder 3"/>
-          <p:cNvSpPr>
-            <a:spLocks noGrp="1"/>
-          </p:cNvSpPr>
-          <p:nvPr>
-            <p:ph sz="half" idx="2"/>
-          </p:nvPr>
-        </p:nvSpPr>
-        <p:spPr/>
-        <p:txBody>
-          <a:bodyPr/>
-          <a:lstStyle/>
-          <a:p>
-            <a:endParaRPr lang="en-GB"/>
-          </a:p>
-        </p:txBody>
-      </p:sp>
-      <p:sp>
-        <p:nvSpPr>
           <p:cNvPr id="5" name="Slide Number Placeholder 4"/>
           <p:cNvSpPr>
             <a:spLocks noGrp="1"/>
@@ -12639,21 +12620,28 @@
       </p:sp>
       <p:pic>
         <p:nvPicPr>
-          <p:cNvPr id="6" name="Picture 5"/>
+          <p:cNvPr id="7" name="Picture 6">
+            <a:extLst>
+              <a:ext uri="{FF2B5EF4-FFF2-40B4-BE49-F238E27FC236}">
+                <a16:creationId xmlns:a16="http://schemas.microsoft.com/office/drawing/2014/main" id="{A815CBF1-F6D3-44B1-A754-F452DB2377AC}"/>
+              </a:ext>
+            </a:extLst>
+          </p:cNvPr>
           <p:cNvPicPr>
             <a:picLocks noChangeAspect="1"/>
           </p:cNvPicPr>
           <p:nvPr/>
         </p:nvPicPr>
-        <p:blipFill rotWithShape="1">
+        <p:blipFill>
           <a:blip r:embed="rId3"/>
-          <a:srcRect b="12201"/>
-          <a:stretch/>
+          <a:stretch>
+            <a:fillRect/>
+          </a:stretch>
         </p:blipFill>
         <p:spPr>
           <a:xfrm>
-            <a:off x="4914266" y="376464"/>
-            <a:ext cx="3506468" cy="6021288"/>
+            <a:off x="4896036" y="188640"/>
+            <a:ext cx="3780420" cy="6606735"/>
           </a:xfrm>
           <a:prstGeom prst="rect">
             <a:avLst/>
@@ -12673,7 +12661,7 @@
     </p:spTree>
     <p:extLst>
       <p:ext uri="{BB962C8B-B14F-4D97-AF65-F5344CB8AC3E}">
-        <p14:creationId xmlns:p14="http://schemas.microsoft.com/office/powerpoint/2010/main" val="4030979938"/>
+        <p14:creationId xmlns:p14="http://schemas.microsoft.com/office/powerpoint/2010/main" val="2543624431"/>
       </p:ext>
     </p:extLst>
   </p:cSld>
@@ -12801,22 +12789,27 @@
       </p:sp>
       <p:pic>
         <p:nvPicPr>
-          <p:cNvPr id="4" name="Picture 3"/>
+          <p:cNvPr id="2" name="Picture 1">
+            <a:extLst>
+              <a:ext uri="{FF2B5EF4-FFF2-40B4-BE49-F238E27FC236}">
+                <a16:creationId xmlns:a16="http://schemas.microsoft.com/office/drawing/2014/main" id="{782F783B-EC76-42E8-A7D7-BF6895623C31}"/>
+              </a:ext>
+            </a:extLst>
+          </p:cNvPr>
           <p:cNvPicPr>
             <a:picLocks noChangeAspect="1"/>
           </p:cNvPicPr>
           <p:nvPr/>
         </p:nvPicPr>
-        <p:blipFill>
+        <p:blipFill rotWithShape="1">
           <a:blip r:embed="rId2"/>
-          <a:stretch>
-            <a:fillRect/>
-          </a:stretch>
+          <a:srcRect b="26901"/>
+          <a:stretch/>
         </p:blipFill>
         <p:spPr>
           <a:xfrm>
-            <a:off x="5060574" y="0"/>
-            <a:ext cx="4099510" cy="6898545"/>
+            <a:off x="5100099" y="1408176"/>
+            <a:ext cx="3471229" cy="5013176"/>
           </a:xfrm>
           <a:prstGeom prst="rect">
             <a:avLst/>
@@ -12836,7 +12829,7 @@
     </p:spTree>
     <p:extLst>
       <p:ext uri="{BB962C8B-B14F-4D97-AF65-F5344CB8AC3E}">
-        <p14:creationId xmlns:p14="http://schemas.microsoft.com/office/powerpoint/2010/main" val="2931379580"/>
+        <p14:creationId xmlns:p14="http://schemas.microsoft.com/office/powerpoint/2010/main" val="453729414"/>
       </p:ext>
     </p:extLst>
   </p:cSld>

</xml_diff>